<commit_message>
feat: automate generation of Lesson 04 resources and add supplementary materials for Unit 2
</commit_message>
<xml_diff>
--- a/Units/English/English_Unit_2/Lesson_Plans/Lesson_04/Lesson_04_Slides.pptx
+++ b/Units/English/English_Unit_2/Lesson_Plans/Lesson_04/Lesson_04_Slides.pptx
@@ -1486,12 +1486,12 @@
         </p:nvSpPr>
         <p:spPr>
           <a:xfrm>
-            <a:off x="507950" y="1666875"/>
-            <a:ext cx="8128099" cy="1432322"/>
+            <a:off x="507950" y="1539776"/>
+            <a:ext cx="8128099" cy="1305520"/>
           </a:xfrm>
           <a:prstGeom prst="roundRect">
             <a:avLst>
-              <a:gd name="adj" fmla="val 13300"/>
+              <a:gd name="adj" fmla="val 14592"/>
             </a:avLst>
           </a:prstGeom>
           <a:solidFill>
@@ -1525,8 +1525,8 @@
         </p:nvSpPr>
         <p:spPr>
           <a:xfrm>
-            <a:off x="685648" y="1920776"/>
-            <a:ext cx="7772704" cy="568970"/>
+            <a:off x="620979" y="1730276"/>
+            <a:ext cx="7902041" cy="568970"/>
           </a:xfrm>
           <a:prstGeom prst="rect">
             <a:avLst/>
@@ -1567,8 +1567,8 @@
         </p:nvSpPr>
         <p:spPr>
           <a:xfrm>
-            <a:off x="685648" y="2489746"/>
-            <a:ext cx="7772704" cy="355550"/>
+            <a:off x="620979" y="2299246"/>
+            <a:ext cx="7902041" cy="355550"/>
           </a:xfrm>
           <a:prstGeom prst="rect">
             <a:avLst/>
@@ -1609,7 +1609,7 @@
         </p:nvSpPr>
         <p:spPr>
           <a:xfrm>
-            <a:off x="426669" y="3606998"/>
+            <a:off x="426669" y="3289697"/>
             <a:ext cx="8290661" cy="426690"/>
           </a:xfrm>
           <a:prstGeom prst="rect">
@@ -1755,12 +1755,12 @@
         </p:nvSpPr>
         <p:spPr>
           <a:xfrm>
-            <a:off x="507950" y="1285875"/>
-            <a:ext cx="8128099" cy="827782"/>
+            <a:off x="507950" y="1158776"/>
+            <a:ext cx="8128099" cy="700980"/>
           </a:xfrm>
           <a:prstGeom prst="roundRect">
             <a:avLst>
-              <a:gd name="adj" fmla="val 23013"/>
+              <a:gd name="adj" fmla="val 27176"/>
             </a:avLst>
           </a:prstGeom>
           <a:solidFill>
@@ -1794,8 +1794,8 @@
         </p:nvSpPr>
         <p:spPr>
           <a:xfrm>
-            <a:off x="761851" y="1539776"/>
-            <a:ext cx="7772704" cy="319980"/>
+            <a:off x="698450" y="1349276"/>
+            <a:ext cx="7902041" cy="319980"/>
           </a:xfrm>
           <a:prstGeom prst="rect">
             <a:avLst/>
@@ -1853,12 +1853,12 @@
         </p:nvSpPr>
         <p:spPr>
           <a:xfrm>
-            <a:off x="507950" y="2494508"/>
-            <a:ext cx="3873550" cy="1871514"/>
+            <a:off x="507950" y="2177207"/>
+            <a:ext cx="3873550" cy="1744712"/>
           </a:xfrm>
           <a:prstGeom prst="roundRect">
             <a:avLst>
-              <a:gd name="adj" fmla="val 10179"/>
+              <a:gd name="adj" fmla="val 10919"/>
             </a:avLst>
           </a:prstGeom>
           <a:solidFill>
@@ -1892,8 +1892,8 @@
         </p:nvSpPr>
         <p:spPr>
           <a:xfrm>
-            <a:off x="761851" y="2748409"/>
-            <a:ext cx="3433063" cy="284411"/>
+            <a:off x="698450" y="2367707"/>
+            <a:ext cx="3562401" cy="284411"/>
           </a:xfrm>
           <a:prstGeom prst="rect">
             <a:avLst/>
@@ -1934,8 +1934,8 @@
         </p:nvSpPr>
         <p:spPr>
           <a:xfrm>
-            <a:off x="761851" y="3096220"/>
-            <a:ext cx="3365748" cy="838200"/>
+            <a:off x="698450" y="2715518"/>
+            <a:ext cx="3492550" cy="838200"/>
           </a:xfrm>
           <a:prstGeom prst="rect">
             <a:avLst/>
@@ -2139,12 +2139,12 @@
         </p:nvSpPr>
         <p:spPr>
           <a:xfrm>
-            <a:off x="507950" y="1285875"/>
-            <a:ext cx="8128099" cy="863352"/>
+            <a:off x="507950" y="1158776"/>
+            <a:ext cx="8128099" cy="736550"/>
           </a:xfrm>
           <a:prstGeom prst="roundRect">
             <a:avLst>
-              <a:gd name="adj" fmla="val 22065"/>
+              <a:gd name="adj" fmla="val 25864"/>
             </a:avLst>
           </a:prstGeom>
           <a:solidFill>
@@ -2178,8 +2178,8 @@
         </p:nvSpPr>
         <p:spPr>
           <a:xfrm>
-            <a:off x="685648" y="1539776"/>
-            <a:ext cx="7772704" cy="355550"/>
+            <a:off x="620979" y="1349276"/>
+            <a:ext cx="7902041" cy="355550"/>
           </a:xfrm>
           <a:prstGeom prst="rect">
             <a:avLst/>
@@ -2220,7 +2220,7 @@
         </p:nvSpPr>
         <p:spPr>
           <a:xfrm>
-            <a:off x="426669" y="2593628"/>
+            <a:off x="426669" y="2276326"/>
             <a:ext cx="8290661" cy="319980"/>
           </a:xfrm>
           <a:prstGeom prst="rect">
@@ -2265,12 +2265,12 @@
         </p:nvSpPr>
         <p:spPr>
           <a:xfrm>
-            <a:off x="507950" y="3294459"/>
-            <a:ext cx="8128099" cy="792212"/>
+            <a:off x="507950" y="2913757"/>
+            <a:ext cx="8128099" cy="665411"/>
           </a:xfrm>
           <a:prstGeom prst="roundRect">
             <a:avLst>
-              <a:gd name="adj" fmla="val 24047"/>
+              <a:gd name="adj" fmla="val 28629"/>
             </a:avLst>
           </a:prstGeom>
           <a:solidFill>
@@ -2304,8 +2304,8 @@
         </p:nvSpPr>
         <p:spPr>
           <a:xfrm>
-            <a:off x="685648" y="3548360"/>
-            <a:ext cx="7772704" cy="284411"/>
+            <a:off x="620979" y="3104257"/>
+            <a:ext cx="7902041" cy="284411"/>
           </a:xfrm>
           <a:prstGeom prst="rect">
             <a:avLst/>
@@ -2481,12 +2481,12 @@
         </p:nvSpPr>
         <p:spPr>
           <a:xfrm>
-            <a:off x="507950" y="1285875"/>
-            <a:ext cx="3873550" cy="1325761"/>
+            <a:off x="507950" y="1158776"/>
+            <a:ext cx="3873550" cy="1198959"/>
           </a:xfrm>
           <a:prstGeom prst="roundRect">
             <a:avLst>
-              <a:gd name="adj" fmla="val 14369"/>
+              <a:gd name="adj" fmla="val 15889"/>
             </a:avLst>
           </a:prstGeom>
           <a:solidFill>
@@ -2520,8 +2520,8 @@
         </p:nvSpPr>
         <p:spPr>
           <a:xfrm>
-            <a:off x="761851" y="1539776"/>
-            <a:ext cx="3433063" cy="319980"/>
+            <a:off x="698450" y="1349276"/>
+            <a:ext cx="3562401" cy="319980"/>
           </a:xfrm>
           <a:prstGeom prst="rect">
             <a:avLst/>
@@ -2562,8 +2562,8 @@
         </p:nvSpPr>
         <p:spPr>
           <a:xfrm>
-            <a:off x="761851" y="1859756"/>
-            <a:ext cx="3433063" cy="497979"/>
+            <a:off x="698450" y="1669256"/>
+            <a:ext cx="3562401" cy="497979"/>
           </a:xfrm>
           <a:prstGeom prst="rect">
             <a:avLst/>
@@ -2604,12 +2604,12 @@
         </p:nvSpPr>
         <p:spPr>
           <a:xfrm>
-            <a:off x="4762500" y="1285875"/>
-            <a:ext cx="3873550" cy="1325761"/>
+            <a:off x="4762500" y="1158776"/>
+            <a:ext cx="3873550" cy="1198959"/>
           </a:xfrm>
           <a:prstGeom prst="roundRect">
             <a:avLst>
-              <a:gd name="adj" fmla="val 14369"/>
+              <a:gd name="adj" fmla="val 15889"/>
             </a:avLst>
           </a:prstGeom>
           <a:solidFill>
@@ -2643,8 +2643,8 @@
         </p:nvSpPr>
         <p:spPr>
           <a:xfrm>
-            <a:off x="5016401" y="1539776"/>
-            <a:ext cx="3433063" cy="319980"/>
+            <a:off x="4953000" y="1349276"/>
+            <a:ext cx="3562401" cy="319980"/>
           </a:xfrm>
           <a:prstGeom prst="rect">
             <a:avLst/>
@@ -2685,8 +2685,8 @@
         </p:nvSpPr>
         <p:spPr>
           <a:xfrm>
-            <a:off x="5016401" y="1859756"/>
-            <a:ext cx="3433063" cy="497979"/>
+            <a:off x="4953000" y="1669256"/>
+            <a:ext cx="3562401" cy="497979"/>
           </a:xfrm>
           <a:prstGeom prst="rect">
             <a:avLst/>
@@ -2727,7 +2727,7 @@
         </p:nvSpPr>
         <p:spPr>
           <a:xfrm>
-            <a:off x="426669" y="3056037"/>
+            <a:off x="426669" y="2738735"/>
             <a:ext cx="8290661" cy="284411"/>
           </a:xfrm>
           <a:prstGeom prst="rect">
@@ -2893,12 +2893,12 @@
         </p:nvSpPr>
         <p:spPr>
           <a:xfrm>
-            <a:off x="507950" y="1285875"/>
-            <a:ext cx="3873550" cy="1005483"/>
+            <a:off x="507950" y="1158776"/>
+            <a:ext cx="3873550" cy="878681"/>
           </a:xfrm>
           <a:prstGeom prst="roundRect">
             <a:avLst>
-              <a:gd name="adj" fmla="val 18946"/>
+              <a:gd name="adj" fmla="val 21680"/>
             </a:avLst>
           </a:prstGeom>
           <a:solidFill>
@@ -2932,8 +2932,8 @@
         </p:nvSpPr>
         <p:spPr>
           <a:xfrm>
-            <a:off x="761851" y="1539776"/>
-            <a:ext cx="3433063" cy="284411"/>
+            <a:off x="698450" y="1349276"/>
+            <a:ext cx="3562401" cy="284411"/>
           </a:xfrm>
           <a:prstGeom prst="rect">
             <a:avLst/>
@@ -2974,8 +2974,8 @@
         </p:nvSpPr>
         <p:spPr>
           <a:xfrm>
-            <a:off x="761851" y="1824186"/>
-            <a:ext cx="3433063" cy="213271"/>
+            <a:off x="698450" y="1633686"/>
+            <a:ext cx="3562401" cy="213271"/>
           </a:xfrm>
           <a:prstGeom prst="rect">
             <a:avLst/>
@@ -3016,12 +3016,12 @@
         </p:nvSpPr>
         <p:spPr>
           <a:xfrm>
-            <a:off x="4762500" y="1285875"/>
-            <a:ext cx="3873550" cy="1005483"/>
+            <a:off x="4762500" y="1158776"/>
+            <a:ext cx="3873550" cy="878681"/>
           </a:xfrm>
           <a:prstGeom prst="roundRect">
             <a:avLst>
-              <a:gd name="adj" fmla="val 18946"/>
+              <a:gd name="adj" fmla="val 21680"/>
             </a:avLst>
           </a:prstGeom>
           <a:solidFill>
@@ -3055,8 +3055,8 @@
         </p:nvSpPr>
         <p:spPr>
           <a:xfrm>
-            <a:off x="5016401" y="1539776"/>
-            <a:ext cx="3433063" cy="284411"/>
+            <a:off x="4953000" y="1349276"/>
+            <a:ext cx="3562401" cy="284411"/>
           </a:xfrm>
           <a:prstGeom prst="rect">
             <a:avLst/>
@@ -3097,8 +3097,8 @@
         </p:nvSpPr>
         <p:spPr>
           <a:xfrm>
-            <a:off x="5016401" y="1824186"/>
-            <a:ext cx="3433063" cy="213271"/>
+            <a:off x="4953000" y="1633686"/>
+            <a:ext cx="3562401" cy="213271"/>
           </a:xfrm>
           <a:prstGeom prst="rect">
             <a:avLst/>
@@ -3240,12 +3240,12 @@
         </p:nvSpPr>
         <p:spPr>
           <a:xfrm>
-            <a:off x="507950" y="1285875"/>
-            <a:ext cx="8128099" cy="827782"/>
+            <a:off x="507950" y="1158776"/>
+            <a:ext cx="8128099" cy="700980"/>
           </a:xfrm>
           <a:prstGeom prst="roundRect">
             <a:avLst>
-              <a:gd name="adj" fmla="val 23013"/>
+              <a:gd name="adj" fmla="val 27176"/>
             </a:avLst>
           </a:prstGeom>
           <a:solidFill>
@@ -3279,8 +3279,8 @@
         </p:nvSpPr>
         <p:spPr>
           <a:xfrm>
-            <a:off x="761851" y="1539776"/>
-            <a:ext cx="7772704" cy="319980"/>
+            <a:off x="698450" y="1349276"/>
+            <a:ext cx="7902041" cy="319980"/>
           </a:xfrm>
           <a:prstGeom prst="rect">
             <a:avLst/>
@@ -3321,7 +3321,7 @@
         </p:nvSpPr>
         <p:spPr>
           <a:xfrm>
-            <a:off x="507950" y="2494508"/>
+            <a:off x="507950" y="2177207"/>
             <a:ext cx="8290661" cy="497979"/>
           </a:xfrm>
           <a:prstGeom prst="rect">
@@ -3366,12 +3366,12 @@
         </p:nvSpPr>
         <p:spPr>
           <a:xfrm>
-            <a:off x="507950" y="3373338"/>
-            <a:ext cx="8128099" cy="756791"/>
+            <a:off x="507950" y="2992636"/>
+            <a:ext cx="8128099" cy="629989"/>
           </a:xfrm>
           <a:prstGeom prst="roundRect">
             <a:avLst>
-              <a:gd name="adj" fmla="val 25172"/>
+              <a:gd name="adj" fmla="val 30239"/>
             </a:avLst>
           </a:prstGeom>
           <a:solidFill>
@@ -3405,8 +3405,8 @@
         </p:nvSpPr>
         <p:spPr>
           <a:xfrm>
-            <a:off x="761851" y="3627239"/>
-            <a:ext cx="7772704" cy="248989"/>
+            <a:off x="698450" y="3183136"/>
+            <a:ext cx="7902041" cy="248989"/>
           </a:xfrm>
           <a:prstGeom prst="rect">
             <a:avLst/>
@@ -3565,12 +3565,12 @@
         </p:nvSpPr>
         <p:spPr>
           <a:xfrm>
-            <a:off x="507950" y="1285875"/>
-            <a:ext cx="8128099" cy="1361033"/>
+            <a:off x="507950" y="1158776"/>
+            <a:ext cx="8128099" cy="1234232"/>
           </a:xfrm>
           <a:prstGeom prst="roundRect">
             <a:avLst>
-              <a:gd name="adj" fmla="val 13997"/>
+              <a:gd name="adj" fmla="val 15435"/>
             </a:avLst>
           </a:prstGeom>
           <a:solidFill>
@@ -3604,8 +3604,8 @@
         </p:nvSpPr>
         <p:spPr>
           <a:xfrm>
-            <a:off x="761851" y="1539776"/>
-            <a:ext cx="7772704" cy="284411"/>
+            <a:off x="698450" y="1349276"/>
+            <a:ext cx="7902041" cy="284411"/>
           </a:xfrm>
           <a:prstGeom prst="rect">
             <a:avLst/>
@@ -3646,8 +3646,8 @@
         </p:nvSpPr>
         <p:spPr>
           <a:xfrm>
-            <a:off x="761851" y="1824186"/>
-            <a:ext cx="7772704" cy="284411"/>
+            <a:off x="698450" y="1633686"/>
+            <a:ext cx="7902041" cy="284411"/>
           </a:xfrm>
           <a:prstGeom prst="rect">
             <a:avLst/>
@@ -3722,8 +3722,8 @@
         </p:nvSpPr>
         <p:spPr>
           <a:xfrm>
-            <a:off x="761851" y="2108597"/>
-            <a:ext cx="7772704" cy="284411"/>
+            <a:off x="698450" y="1918097"/>
+            <a:ext cx="7902041" cy="284411"/>
           </a:xfrm>
           <a:prstGeom prst="rect">
             <a:avLst/>
@@ -3764,12 +3764,12 @@
         </p:nvSpPr>
         <p:spPr>
           <a:xfrm>
-            <a:off x="507950" y="3027759"/>
-            <a:ext cx="8128099" cy="756791"/>
+            <a:off x="507950" y="2710458"/>
+            <a:ext cx="8128099" cy="629989"/>
           </a:xfrm>
           <a:prstGeom prst="roundRect">
             <a:avLst>
-              <a:gd name="adj" fmla="val 25172"/>
+              <a:gd name="adj" fmla="val 30239"/>
             </a:avLst>
           </a:prstGeom>
           <a:solidFill>
@@ -3803,8 +3803,8 @@
         </p:nvSpPr>
         <p:spPr>
           <a:xfrm>
-            <a:off x="761851" y="3281660"/>
-            <a:ext cx="7772704" cy="248989"/>
+            <a:off x="698450" y="2900958"/>
+            <a:ext cx="7902041" cy="248989"/>
           </a:xfrm>
           <a:prstGeom prst="rect">
             <a:avLst/>

</xml_diff>